<commit_message>
PHS1000 deck: one-line 2024 headline
Co-Authored-By: Claude Fable 5.1 <noreply@anthropic.com>
Claude-Session: https://claude.ai/code/session_01Xxifyqc7p6YFuCpaP2Ptbi
</commit_message>
<xml_diff>
--- a/projects/phs1000/PHS1000_Health_Economics_27Oct2026.pptx
+++ b/projects/phs1000/PHS1000_Health_Economics_27Oct2026.pptx
@@ -7083,14 +7083,14 @@
               <a:buNone/>
             </a:pPr>
             <a:r>
-              <a:rPr lang="en-US" sz="2000" dirty="0">
+              <a:rPr lang="en-US" sz="1800" dirty="0">
                 <a:solidFill>
                   <a:srgbClr val="BA0C2F"/>
                 </a:solidFill>
               </a:rPr>
-              <a:t>5.3 trillion dollars  ·  15,474 dollars per person  ·  18 percent of GDP  ·  43 percent public money</a:t>
-            </a:r>
-            <a:endParaRPr lang="en-US" sz="2000" dirty="0"/>
+              <a:t>5.3 trillion dollars  ·  15,474 per person  ·  18 percent of GDP  ·  43 percent public</a:t>
+            </a:r>
+            <a:endParaRPr lang="en-US" sz="1800" dirty="0"/>
           </a:p>
         </p:txBody>
       </p:sp>

</xml_diff>